<commit_message>
fix: email send fix + clear password btn
</commit_message>
<xml_diff>
--- a/LedgerelyTutorGuide.pptx
+++ b/LedgerelyTutorGuide.pptx
@@ -207,7 +207,7 @@
           <a:p>
             <a:fld id="{BD7AAFBB-AF41-154A-B3B9-CEE10C7BD486}" type="datetimeFigureOut">
               <a:rPr lang="en-US" smtClean="0"/>
-              <a:t>7/20/26</a:t>
+              <a:t>7/30/26</a:t>
             </a:fld>
             <a:endParaRPr lang="en-US"/>
           </a:p>
@@ -3039,7 +3039,7 @@
           <a:p>
             <a:fld id="{D0CDB39E-5683-AD44-89B1-94B75B088CED}" type="datetimeFigureOut">
               <a:rPr lang="en-US" smtClean="0"/>
-              <a:t>7/20/26</a:t>
+              <a:t>7/30/26</a:t>
             </a:fld>
             <a:endParaRPr lang="en-US"/>
           </a:p>
@@ -3237,7 +3237,7 @@
           <a:p>
             <a:fld id="{D0CDB39E-5683-AD44-89B1-94B75B088CED}" type="datetimeFigureOut">
               <a:rPr lang="en-US" smtClean="0"/>
-              <a:t>7/20/26</a:t>
+              <a:t>7/30/26</a:t>
             </a:fld>
             <a:endParaRPr lang="en-US"/>
           </a:p>
@@ -3445,7 +3445,7 @@
           <a:p>
             <a:fld id="{D0CDB39E-5683-AD44-89B1-94B75B088CED}" type="datetimeFigureOut">
               <a:rPr lang="en-US" smtClean="0"/>
-              <a:t>7/20/26</a:t>
+              <a:t>7/30/26</a:t>
             </a:fld>
             <a:endParaRPr lang="en-US"/>
           </a:p>
@@ -3678,7 +3678,7 @@
           <a:p>
             <a:fld id="{D0CDB39E-5683-AD44-89B1-94B75B088CED}" type="datetimeFigureOut">
               <a:rPr lang="en-US" smtClean="0"/>
-              <a:t>7/20/26</a:t>
+              <a:t>7/30/26</a:t>
             </a:fld>
             <a:endParaRPr lang="en-US"/>
           </a:p>
@@ -3953,7 +3953,7 @@
           <a:p>
             <a:fld id="{D0CDB39E-5683-AD44-89B1-94B75B088CED}" type="datetimeFigureOut">
               <a:rPr lang="en-US" smtClean="0"/>
-              <a:t>7/20/26</a:t>
+              <a:t>7/30/26</a:t>
             </a:fld>
             <a:endParaRPr lang="en-US"/>
           </a:p>
@@ -4218,7 +4218,7 @@
           <a:p>
             <a:fld id="{D0CDB39E-5683-AD44-89B1-94B75B088CED}" type="datetimeFigureOut">
               <a:rPr lang="en-US" smtClean="0"/>
-              <a:t>7/20/26</a:t>
+              <a:t>7/30/26</a:t>
             </a:fld>
             <a:endParaRPr lang="en-US"/>
           </a:p>
@@ -4630,7 +4630,7 @@
           <a:p>
             <a:fld id="{D0CDB39E-5683-AD44-89B1-94B75B088CED}" type="datetimeFigureOut">
               <a:rPr lang="en-US" smtClean="0"/>
-              <a:t>7/20/26</a:t>
+              <a:t>7/30/26</a:t>
             </a:fld>
             <a:endParaRPr lang="en-US"/>
           </a:p>
@@ -4771,7 +4771,7 @@
           <a:p>
             <a:fld id="{D0CDB39E-5683-AD44-89B1-94B75B088CED}" type="datetimeFigureOut">
               <a:rPr lang="en-US" smtClean="0"/>
-              <a:t>7/20/26</a:t>
+              <a:t>7/30/26</a:t>
             </a:fld>
             <a:endParaRPr lang="en-US"/>
           </a:p>
@@ -4884,7 +4884,7 @@
           <a:p>
             <a:fld id="{D0CDB39E-5683-AD44-89B1-94B75B088CED}" type="datetimeFigureOut">
               <a:rPr lang="en-US" smtClean="0"/>
-              <a:t>7/20/26</a:t>
+              <a:t>7/30/26</a:t>
             </a:fld>
             <a:endParaRPr lang="en-US"/>
           </a:p>
@@ -5195,7 +5195,7 @@
           <a:p>
             <a:fld id="{D0CDB39E-5683-AD44-89B1-94B75B088CED}" type="datetimeFigureOut">
               <a:rPr lang="en-US" smtClean="0"/>
-              <a:t>7/20/26</a:t>
+              <a:t>7/30/26</a:t>
             </a:fld>
             <a:endParaRPr lang="en-US"/>
           </a:p>
@@ -5483,7 +5483,7 @@
           <a:p>
             <a:fld id="{D0CDB39E-5683-AD44-89B1-94B75B088CED}" type="datetimeFigureOut">
               <a:rPr lang="en-US" smtClean="0"/>
-              <a:t>7/20/26</a:t>
+              <a:t>7/30/26</a:t>
             </a:fld>
             <a:endParaRPr lang="en-US"/>
           </a:p>
@@ -5724,7 +5724,7 @@
           <a:p>
             <a:fld id="{D0CDB39E-5683-AD44-89B1-94B75B088CED}" type="datetimeFigureOut">
               <a:rPr lang="en-US" smtClean="0"/>
-              <a:t>7/20/26</a:t>
+              <a:t>7/30/26</a:t>
             </a:fld>
             <a:endParaRPr lang="en-US"/>
           </a:p>
@@ -6200,8 +6200,8 @@
         </p:nvSpPr>
         <p:spPr>
           <a:xfrm>
-            <a:off x="-2034294" y="2041506"/>
-            <a:ext cx="1851414" cy="1384995"/>
+            <a:off x="6790188" y="2221810"/>
+            <a:ext cx="3345485" cy="461665"/>
           </a:xfrm>
           <a:prstGeom prst="rect">
             <a:avLst/>
@@ -6229,15 +6229,20 @@
           <a:p>
             <a:pPr algn="ctr"/>
             <a:r>
-              <a:rPr lang="en-US" sz="2800" b="1" cap="none" spc="0">
-                <a:ln/>
+              <a:rPr lang="en-US" sz="2400" b="1" dirty="0">
                 <a:solidFill>
                   <a:srgbClr val="C2D82E"/>
                 </a:solidFill>
-                <a:effectLst/>
-              </a:rPr>
-              <a:t>Why Ledgerely ?</a:t>
-            </a:r>
+              </a:rPr>
+              <a:t>Dashboard</a:t>
+            </a:r>
+            <a:endParaRPr lang="en-US" sz="2400" b="1" cap="none" spc="0" dirty="0">
+              <a:ln/>
+              <a:solidFill>
+                <a:srgbClr val="C2D82E"/>
+              </a:solidFill>
+              <a:effectLst/>
+            </a:endParaRPr>
           </a:p>
         </p:txBody>
       </p:sp>
@@ -6255,7 +6260,7 @@
         </p:nvSpPr>
         <p:spPr>
           <a:xfrm>
-            <a:off x="-1555322" y="606991"/>
+            <a:off x="6790188" y="272140"/>
             <a:ext cx="1442112" cy="400110"/>
           </a:xfrm>
           <a:prstGeom prst="rect">
@@ -6291,8 +6296,24 @@
                 </a:solidFill>
                 <a:effectLst/>
               </a:rPr>
-              <a:t>Lesson 1</a:t>
-            </a:r>
+              <a:t>Lesson </a:t>
+            </a:r>
+            <a:r>
+              <a:rPr lang="en-US" sz="2000" b="1" dirty="0">
+                <a:ln/>
+                <a:solidFill>
+                  <a:srgbClr val="C2D82E"/>
+                </a:solidFill>
+              </a:rPr>
+              <a:t>5</a:t>
+            </a:r>
+            <a:endParaRPr lang="en-US" sz="2000" b="1" cap="none" spc="0" dirty="0">
+              <a:ln/>
+              <a:solidFill>
+                <a:srgbClr val="C2D82E"/>
+              </a:solidFill>
+              <a:effectLst/>
+            </a:endParaRPr>
           </a:p>
         </p:txBody>
       </p:sp>

</xml_diff>

<commit_message>
fix: cosmetics + workbook chart default colors
</commit_message>
<xml_diff>
--- a/LedgerelyTutorGuide.pptx
+++ b/LedgerelyTutorGuide.pptx
@@ -207,7 +207,7 @@
           <a:p>
             <a:fld id="{BD7AAFBB-AF41-154A-B3B9-CEE10C7BD486}" type="datetimeFigureOut">
               <a:rPr lang="en-US" smtClean="0"/>
-              <a:t>7/30/26</a:t>
+              <a:t>8/27/26</a:t>
             </a:fld>
             <a:endParaRPr lang="en-US"/>
           </a:p>
@@ -3039,7 +3039,7 @@
           <a:p>
             <a:fld id="{D0CDB39E-5683-AD44-89B1-94B75B088CED}" type="datetimeFigureOut">
               <a:rPr lang="en-US" smtClean="0"/>
-              <a:t>7/30/26</a:t>
+              <a:t>8/27/26</a:t>
             </a:fld>
             <a:endParaRPr lang="en-US"/>
           </a:p>
@@ -3237,7 +3237,7 @@
           <a:p>
             <a:fld id="{D0CDB39E-5683-AD44-89B1-94B75B088CED}" type="datetimeFigureOut">
               <a:rPr lang="en-US" smtClean="0"/>
-              <a:t>7/30/26</a:t>
+              <a:t>8/27/26</a:t>
             </a:fld>
             <a:endParaRPr lang="en-US"/>
           </a:p>
@@ -3445,7 +3445,7 @@
           <a:p>
             <a:fld id="{D0CDB39E-5683-AD44-89B1-94B75B088CED}" type="datetimeFigureOut">
               <a:rPr lang="en-US" smtClean="0"/>
-              <a:t>7/30/26</a:t>
+              <a:t>8/27/26</a:t>
             </a:fld>
             <a:endParaRPr lang="en-US"/>
           </a:p>
@@ -3678,7 +3678,7 @@
           <a:p>
             <a:fld id="{D0CDB39E-5683-AD44-89B1-94B75B088CED}" type="datetimeFigureOut">
               <a:rPr lang="en-US" smtClean="0"/>
-              <a:t>7/30/26</a:t>
+              <a:t>8/27/26</a:t>
             </a:fld>
             <a:endParaRPr lang="en-US"/>
           </a:p>
@@ -3953,7 +3953,7 @@
           <a:p>
             <a:fld id="{D0CDB39E-5683-AD44-89B1-94B75B088CED}" type="datetimeFigureOut">
               <a:rPr lang="en-US" smtClean="0"/>
-              <a:t>7/30/26</a:t>
+              <a:t>8/27/26</a:t>
             </a:fld>
             <a:endParaRPr lang="en-US"/>
           </a:p>
@@ -4218,7 +4218,7 @@
           <a:p>
             <a:fld id="{D0CDB39E-5683-AD44-89B1-94B75B088CED}" type="datetimeFigureOut">
               <a:rPr lang="en-US" smtClean="0"/>
-              <a:t>7/30/26</a:t>
+              <a:t>8/27/26</a:t>
             </a:fld>
             <a:endParaRPr lang="en-US"/>
           </a:p>
@@ -4630,7 +4630,7 @@
           <a:p>
             <a:fld id="{D0CDB39E-5683-AD44-89B1-94B75B088CED}" type="datetimeFigureOut">
               <a:rPr lang="en-US" smtClean="0"/>
-              <a:t>7/30/26</a:t>
+              <a:t>8/27/26</a:t>
             </a:fld>
             <a:endParaRPr lang="en-US"/>
           </a:p>
@@ -4771,7 +4771,7 @@
           <a:p>
             <a:fld id="{D0CDB39E-5683-AD44-89B1-94B75B088CED}" type="datetimeFigureOut">
               <a:rPr lang="en-US" smtClean="0"/>
-              <a:t>7/30/26</a:t>
+              <a:t>8/27/26</a:t>
             </a:fld>
             <a:endParaRPr lang="en-US"/>
           </a:p>
@@ -4884,7 +4884,7 @@
           <a:p>
             <a:fld id="{D0CDB39E-5683-AD44-89B1-94B75B088CED}" type="datetimeFigureOut">
               <a:rPr lang="en-US" smtClean="0"/>
-              <a:t>7/30/26</a:t>
+              <a:t>8/27/26</a:t>
             </a:fld>
             <a:endParaRPr lang="en-US"/>
           </a:p>
@@ -5195,7 +5195,7 @@
           <a:p>
             <a:fld id="{D0CDB39E-5683-AD44-89B1-94B75B088CED}" type="datetimeFigureOut">
               <a:rPr lang="en-US" smtClean="0"/>
-              <a:t>7/30/26</a:t>
+              <a:t>8/27/26</a:t>
             </a:fld>
             <a:endParaRPr lang="en-US"/>
           </a:p>
@@ -5483,7 +5483,7 @@
           <a:p>
             <a:fld id="{D0CDB39E-5683-AD44-89B1-94B75B088CED}" type="datetimeFigureOut">
               <a:rPr lang="en-US" smtClean="0"/>
-              <a:t>7/30/26</a:t>
+              <a:t>8/27/26</a:t>
             </a:fld>
             <a:endParaRPr lang="en-US"/>
           </a:p>
@@ -5724,7 +5724,7 @@
           <a:p>
             <a:fld id="{D0CDB39E-5683-AD44-89B1-94B75B088CED}" type="datetimeFigureOut">
               <a:rPr lang="en-US" smtClean="0"/>
-              <a:t>7/30/26</a:t>
+              <a:t>8/27/26</a:t>
             </a:fld>
             <a:endParaRPr lang="en-US"/>
           </a:p>
@@ -6200,8 +6200,8 @@
         </p:nvSpPr>
         <p:spPr>
           <a:xfrm>
-            <a:off x="6790188" y="2221810"/>
-            <a:ext cx="3345485" cy="461665"/>
+            <a:off x="6790188" y="2336110"/>
+            <a:ext cx="3345485" cy="369332"/>
           </a:xfrm>
           <a:prstGeom prst="rect">
             <a:avLst/>
@@ -6229,14 +6229,14 @@
           <a:p>
             <a:pPr algn="ctr"/>
             <a:r>
-              <a:rPr lang="en-US" sz="2400" b="1" dirty="0">
+              <a:rPr lang="en-US" b="1" dirty="0">
                 <a:solidFill>
                   <a:srgbClr val="C2D82E"/>
                 </a:solidFill>
               </a:rPr>
-              <a:t>Dashboard</a:t>
-            </a:r>
-            <a:endParaRPr lang="en-US" sz="2400" b="1" cap="none" spc="0" dirty="0">
+              <a:t>Data source – Inbuilt Query 2</a:t>
+            </a:r>
+            <a:endParaRPr lang="en-US" b="1" cap="none" spc="0" dirty="0">
               <a:ln/>
               <a:solidFill>
                 <a:srgbClr val="C2D82E"/>
@@ -6305,7 +6305,7 @@
                   <a:srgbClr val="C2D82E"/>
                 </a:solidFill>
               </a:rPr>
-              <a:t>5</a:t>
+              <a:t>14</a:t>
             </a:r>
             <a:endParaRPr lang="en-US" sz="2000" b="1" cap="none" spc="0" dirty="0">
               <a:ln/>

</xml_diff>